<commit_message>
Remove the cloud cost from slides and docs
The cost tile on the timing slide now shows the median time per epoch (about 19 s); the cost is also gone from the speaker notes, the report and the guide.
</commit_message>
<xml_diff>
--- a/slides/Malaria_Phase2_Long.pptx
+++ b/slides/Malaria_Phase2_Long.pptx
@@ -2180,7 +2180,7 @@
           <a:p>
             <a:r>
               <a:rPr lang="en-US" dirty="0"/>
-              <a:t>Left: the training time of each of our ten folds, one RTX 4090 per fold, all running at the same time; about 11 minutes each, with fold 3 slower because it landed on a slower host. Right: the paper needed 286 minutes per fold on a GTX 1050, so we are about 25 times faster per fold. The whole run cost about 4.8 dollars, and the ten trained models are published, so nobody has to retrain.</a:t>
+              <a:t>Left: the training time of each of our ten folds, one RTX 4090 per fold, all running at the same time; about 11 minutes each, with fold 3 slower because it landed on a slower host. Right: the paper needed 286 minutes per fold on a GTX 1050, so we are about 25 times faster per fold. A typical epoch took about 19 seconds. The ten trained models are published, so nobody has to retrain.</a:t>
             </a:r>
             <a:endParaRPr lang="en-US" dirty="0"/>
           </a:p>
@@ -4157,6 +4157,10 @@
             <a:prstDash val="solid"/>
           </a:ln>
         </p:spPr>
+        <p:txBody>
+          <a:bodyPr/>
+          <a:p/>
+        </p:txBody>
       </p:sp>
       <p:sp>
         <p:nvSpPr>
@@ -4268,6 +4272,10 @@
             <a:prstDash val="solid"/>
           </a:ln>
         </p:spPr>
+        <p:txBody>
+          <a:bodyPr/>
+          <a:p/>
+        </p:txBody>
       </p:sp>
       <p:sp>
         <p:nvSpPr>
@@ -4379,6 +4387,10 @@
             <a:prstDash val="solid"/>
           </a:ln>
         </p:spPr>
+        <p:txBody>
+          <a:bodyPr/>
+          <a:p/>
+        </p:txBody>
       </p:sp>
       <p:sp>
         <p:nvSpPr>
@@ -4490,6 +4502,10 @@
             <a:prstDash val="solid"/>
           </a:ln>
         </p:spPr>
+        <p:txBody>
+          <a:bodyPr/>
+          <a:p/>
+        </p:txBody>
       </p:sp>
       <p:sp>
         <p:nvSpPr>
@@ -4740,6 +4756,10 @@
             <a:prstDash val="solid"/>
           </a:ln>
         </p:spPr>
+        <p:txBody>
+          <a:bodyPr/>
+          <a:p/>
+        </p:txBody>
       </p:sp>
       <p:sp>
         <p:nvSpPr>
@@ -4765,6 +4785,10 @@
             <a:prstDash val="solid"/>
           </a:ln>
         </p:spPr>
+        <p:txBody>
+          <a:bodyPr/>
+          <a:p/>
+        </p:txBody>
       </p:sp>
       <p:pic>
         <p:nvPicPr>
@@ -4902,6 +4926,10 @@
             <a:prstDash val="solid"/>
           </a:ln>
         </p:spPr>
+        <p:txBody>
+          <a:bodyPr/>
+          <a:p/>
+        </p:txBody>
       </p:sp>
       <p:sp>
         <p:nvSpPr>
@@ -4927,6 +4955,10 @@
             <a:prstDash val="solid"/>
           </a:ln>
         </p:spPr>
+        <p:txBody>
+          <a:bodyPr/>
+          <a:p/>
+        </p:txBody>
       </p:sp>
       <p:pic>
         <p:nvPicPr>
@@ -5064,6 +5096,10 @@
             <a:prstDash val="solid"/>
           </a:ln>
         </p:spPr>
+        <p:txBody>
+          <a:bodyPr/>
+          <a:p/>
+        </p:txBody>
       </p:sp>
       <p:sp>
         <p:nvSpPr>
@@ -5089,6 +5125,10 @@
             <a:prstDash val="solid"/>
           </a:ln>
         </p:spPr>
+        <p:txBody>
+          <a:bodyPr/>
+          <a:p/>
+        </p:txBody>
       </p:sp>
       <p:pic>
         <p:nvPicPr>
@@ -5226,6 +5266,10 @@
             <a:prstDash val="solid"/>
           </a:ln>
         </p:spPr>
+        <p:txBody>
+          <a:bodyPr/>
+          <a:p/>
+        </p:txBody>
       </p:sp>
       <p:sp>
         <p:nvSpPr>
@@ -5251,6 +5295,10 @@
             <a:prstDash val="solid"/>
           </a:ln>
         </p:spPr>
+        <p:txBody>
+          <a:bodyPr/>
+          <a:p/>
+        </p:txBody>
       </p:sp>
       <p:pic>
         <p:nvPicPr>
@@ -5534,6 +5582,10 @@
             <a:prstDash val="solid"/>
           </a:ln>
         </p:spPr>
+        <p:txBody>
+          <a:bodyPr/>
+          <a:p/>
+        </p:txBody>
       </p:sp>
       <p:sp>
         <p:nvSpPr>
@@ -5559,6 +5611,10 @@
             <a:prstDash val="solid"/>
           </a:ln>
         </p:spPr>
+        <p:txBody>
+          <a:bodyPr/>
+          <a:p/>
+        </p:txBody>
       </p:sp>
       <p:pic>
         <p:nvPicPr>
@@ -5696,6 +5752,10 @@
             <a:prstDash val="solid"/>
           </a:ln>
         </p:spPr>
+        <p:txBody>
+          <a:bodyPr/>
+          <a:p/>
+        </p:txBody>
       </p:sp>
       <p:sp>
         <p:nvSpPr>
@@ -5721,6 +5781,10 @@
             <a:prstDash val="solid"/>
           </a:ln>
         </p:spPr>
+        <p:txBody>
+          <a:bodyPr/>
+          <a:p/>
+        </p:txBody>
       </p:sp>
       <p:pic>
         <p:nvPicPr>
@@ -5858,6 +5922,10 @@
             <a:prstDash val="solid"/>
           </a:ln>
         </p:spPr>
+        <p:txBody>
+          <a:bodyPr/>
+          <a:p/>
+        </p:txBody>
       </p:sp>
       <p:sp>
         <p:nvSpPr>
@@ -5883,6 +5951,10 @@
             <a:prstDash val="solid"/>
           </a:ln>
         </p:spPr>
+        <p:txBody>
+          <a:bodyPr/>
+          <a:p/>
+        </p:txBody>
       </p:sp>
       <p:pic>
         <p:nvPicPr>
@@ -6020,6 +6092,10 @@
             <a:prstDash val="solid"/>
           </a:ln>
         </p:spPr>
+        <p:txBody>
+          <a:bodyPr/>
+          <a:p/>
+        </p:txBody>
       </p:sp>
       <p:sp>
         <p:nvSpPr>
@@ -6045,6 +6121,10 @@
             <a:prstDash val="solid"/>
           </a:ln>
         </p:spPr>
+        <p:txBody>
+          <a:bodyPr/>
+          <a:p/>
+        </p:txBody>
       </p:sp>
       <p:pic>
         <p:nvPicPr>
@@ -6182,6 +6262,10 @@
             <a:prstDash val="solid"/>
           </a:ln>
         </p:spPr>
+        <p:txBody>
+          <a:bodyPr/>
+          <a:p/>
+        </p:txBody>
       </p:sp>
       <p:sp>
         <p:nvSpPr>
@@ -6207,6 +6291,10 @@
             <a:prstDash val="solid"/>
           </a:ln>
         </p:spPr>
+        <p:txBody>
+          <a:bodyPr/>
+          <a:p/>
+        </p:txBody>
       </p:sp>
       <p:pic>
         <p:nvPicPr>
@@ -6577,6 +6665,10 @@
             <a:prstDash val="solid"/>
           </a:ln>
         </p:spPr>
+        <p:txBody>
+          <a:bodyPr/>
+          <a:p/>
+        </p:txBody>
       </p:sp>
       <p:pic>
         <p:nvPicPr>
@@ -6682,6 +6774,10 @@
             <a:prstDash val="solid"/>
           </a:ln>
         </p:spPr>
+        <p:txBody>
+          <a:bodyPr/>
+          <a:p/>
+        </p:txBody>
       </p:sp>
       <p:pic>
         <p:nvPicPr>
@@ -6787,6 +6883,10 @@
             <a:prstDash val="solid"/>
           </a:ln>
         </p:spPr>
+        <p:txBody>
+          <a:bodyPr/>
+          <a:p/>
+        </p:txBody>
       </p:sp>
       <p:pic>
         <p:nvPicPr>
@@ -6892,6 +6992,10 @@
             <a:prstDash val="solid"/>
           </a:ln>
         </p:spPr>
+        <p:txBody>
+          <a:bodyPr/>
+          <a:p/>
+        </p:txBody>
       </p:sp>
       <p:pic>
         <p:nvPicPr>
@@ -6999,6 +7103,10 @@
             <a:prstDash val="solid"/>
           </a:ln>
         </p:spPr>
+        <p:txBody>
+          <a:bodyPr/>
+          <a:p/>
+        </p:txBody>
       </p:sp>
       <p:sp>
         <p:nvSpPr>
@@ -8404,6 +8512,10 @@
             <a:prstDash val="solid"/>
           </a:ln>
         </p:spPr>
+        <p:txBody>
+          <a:bodyPr/>
+          <a:p/>
+        </p:txBody>
       </p:sp>
       <p:sp>
         <p:nvSpPr>
@@ -8539,6 +8651,10 @@
             <a:prstDash val="solid"/>
           </a:ln>
         </p:spPr>
+        <p:txBody>
+          <a:bodyPr/>
+          <a:p/>
+        </p:txBody>
       </p:sp>
       <p:sp>
         <p:nvSpPr>
@@ -8674,6 +8790,10 @@
             <a:prstDash val="solid"/>
           </a:ln>
         </p:spPr>
+        <p:txBody>
+          <a:bodyPr/>
+          <a:p/>
+        </p:txBody>
       </p:sp>
       <p:sp>
         <p:nvSpPr>
@@ -8773,6 +8893,10 @@
             <a:prstDash val="solid"/>
           </a:ln>
         </p:spPr>
+        <p:txBody>
+          <a:bodyPr/>
+          <a:p/>
+        </p:txBody>
       </p:sp>
       <p:sp>
         <p:nvSpPr>
@@ -8798,6 +8922,10 @@
             <a:prstDash val="solid"/>
           </a:ln>
         </p:spPr>
+        <p:txBody>
+          <a:bodyPr/>
+          <a:p/>
+        </p:txBody>
       </p:sp>
       <p:pic>
         <p:nvPicPr>
@@ -11098,6 +11226,10 @@
             <a:prstDash val="solid"/>
           </a:ln>
         </p:spPr>
+        <p:txBody>
+          <a:bodyPr/>
+          <a:p/>
+        </p:txBody>
       </p:sp>
       <p:sp>
         <p:nvSpPr>
@@ -11123,6 +11255,10 @@
             <a:prstDash val="solid"/>
           </a:ln>
         </p:spPr>
+        <p:txBody>
+          <a:bodyPr/>
+          <a:p/>
+        </p:txBody>
       </p:sp>
       <p:pic>
         <p:nvPicPr>
@@ -11274,6 +11410,10 @@
             <a:prstDash val="solid"/>
           </a:ln>
         </p:spPr>
+        <p:txBody>
+          <a:bodyPr/>
+          <a:p/>
+        </p:txBody>
       </p:sp>
       <p:sp>
         <p:nvSpPr>
@@ -11299,6 +11439,10 @@
             <a:prstDash val="solid"/>
           </a:ln>
         </p:spPr>
+        <p:txBody>
+          <a:bodyPr/>
+          <a:p/>
+        </p:txBody>
       </p:sp>
       <p:pic>
         <p:nvPicPr>
@@ -12154,6 +12298,10 @@
             <a:prstDash val="solid"/>
           </a:ln>
         </p:spPr>
+        <p:txBody>
+          <a:bodyPr/>
+          <a:p/>
+        </p:txBody>
       </p:sp>
       <p:sp>
         <p:nvSpPr>
@@ -12363,6 +12511,10 @@
             <a:prstDash val="solid"/>
           </a:ln>
         </p:spPr>
+        <p:txBody>
+          <a:bodyPr/>
+          <a:p/>
+        </p:txBody>
       </p:sp>
       <p:sp>
         <p:nvSpPr>
@@ -12440,6 +12592,10 @@
             <a:prstDash val="solid"/>
           </a:ln>
         </p:spPr>
+        <p:txBody>
+          <a:bodyPr/>
+          <a:p/>
+        </p:txBody>
       </p:sp>
       <p:sp>
         <p:nvSpPr>
@@ -12517,6 +12673,10 @@
             <a:prstDash val="solid"/>
           </a:ln>
         </p:spPr>
+        <p:txBody>
+          <a:bodyPr/>
+          <a:p/>
+        </p:txBody>
       </p:sp>
       <p:sp>
         <p:nvSpPr>
@@ -12594,6 +12754,10 @@
             <a:prstDash val="solid"/>
           </a:ln>
         </p:spPr>
+        <p:txBody>
+          <a:bodyPr/>
+          <a:p/>
+        </p:txBody>
       </p:sp>
       <p:sp>
         <p:nvSpPr>
@@ -12671,6 +12835,10 @@
             <a:prstDash val="solid"/>
           </a:ln>
         </p:spPr>
+        <p:txBody>
+          <a:bodyPr/>
+          <a:p/>
+        </p:txBody>
       </p:sp>
       <p:sp>
         <p:nvSpPr>
@@ -12745,6 +12913,10 @@
             <a:tailEnd type="triangle"/>
           </a:ln>
         </p:spPr>
+        <p:txBody>
+          <a:bodyPr/>
+          <a:p/>
+        </p:txBody>
       </p:sp>
       <p:sp>
         <p:nvSpPr>
@@ -12769,6 +12941,10 @@
             <a:tailEnd type="triangle"/>
           </a:ln>
         </p:spPr>
+        <p:txBody>
+          <a:bodyPr/>
+          <a:p/>
+        </p:txBody>
       </p:sp>
       <p:sp>
         <p:nvSpPr>
@@ -12793,6 +12969,10 @@
             <a:tailEnd type="triangle"/>
           </a:ln>
         </p:spPr>
+        <p:txBody>
+          <a:bodyPr/>
+          <a:p/>
+        </p:txBody>
       </p:sp>
       <p:sp>
         <p:nvSpPr>
@@ -12817,6 +12997,10 @@
             <a:tailEnd type="triangle"/>
           </a:ln>
         </p:spPr>
+        <p:txBody>
+          <a:bodyPr/>
+          <a:p/>
+        </p:txBody>
       </p:sp>
       <p:sp>
         <p:nvSpPr>
@@ -12844,6 +13028,10 @@
             <a:prstDash val="solid"/>
           </a:ln>
         </p:spPr>
+        <p:txBody>
+          <a:bodyPr/>
+          <a:p/>
+        </p:txBody>
       </p:sp>
       <p:sp>
         <p:nvSpPr>
@@ -12921,6 +13109,10 @@
             <a:prstDash val="solid"/>
           </a:ln>
         </p:spPr>
+        <p:txBody>
+          <a:bodyPr/>
+          <a:p/>
+        </p:txBody>
       </p:sp>
       <p:sp>
         <p:nvSpPr>
@@ -12995,6 +13187,10 @@
             <a:tailEnd type="triangle"/>
           </a:ln>
         </p:spPr>
+        <p:txBody>
+          <a:bodyPr/>
+          <a:p/>
+        </p:txBody>
       </p:sp>
       <p:sp>
         <p:nvSpPr>
@@ -13019,6 +13215,10 @@
             <a:tailEnd type="triangle"/>
           </a:ln>
         </p:spPr>
+        <p:txBody>
+          <a:bodyPr/>
+          <a:p/>
+        </p:txBody>
       </p:sp>
       <p:sp>
         <p:nvSpPr>
@@ -13043,6 +13243,10 @@
             <a:tailEnd type="triangle"/>
           </a:ln>
         </p:spPr>
+        <p:txBody>
+          <a:bodyPr/>
+          <a:p/>
+        </p:txBody>
       </p:sp>
       <p:sp>
         <p:nvSpPr>
@@ -13252,6 +13456,10 @@
             <a:prstDash val="solid"/>
           </a:ln>
         </p:spPr>
+        <p:txBody>
+          <a:bodyPr/>
+          <a:p/>
+        </p:txBody>
       </p:sp>
       <p:sp>
         <p:nvSpPr>
@@ -13329,6 +13537,10 @@
             <a:prstDash val="solid"/>
           </a:ln>
         </p:spPr>
+        <p:txBody>
+          <a:bodyPr/>
+          <a:p/>
+        </p:txBody>
       </p:sp>
       <p:sp>
         <p:nvSpPr>
@@ -13406,6 +13618,10 @@
             <a:prstDash val="solid"/>
           </a:ln>
         </p:spPr>
+        <p:txBody>
+          <a:bodyPr/>
+          <a:p/>
+        </p:txBody>
       </p:sp>
       <p:sp>
         <p:nvSpPr>
@@ -13480,6 +13696,10 @@
             <a:tailEnd type="triangle"/>
           </a:ln>
         </p:spPr>
+        <p:txBody>
+          <a:bodyPr/>
+          <a:p/>
+        </p:txBody>
       </p:sp>
       <p:sp>
         <p:nvSpPr>
@@ -13504,6 +13724,10 @@
             <a:tailEnd type="triangle"/>
           </a:ln>
         </p:spPr>
+        <p:txBody>
+          <a:bodyPr/>
+          <a:p/>
+        </p:txBody>
       </p:sp>
       <p:sp>
         <p:nvSpPr>
@@ -13531,6 +13755,10 @@
             <a:prstDash val="solid"/>
           </a:ln>
         </p:spPr>
+        <p:txBody>
+          <a:bodyPr/>
+          <a:p/>
+        </p:txBody>
       </p:sp>
       <p:sp>
         <p:nvSpPr>
@@ -13608,6 +13836,10 @@
             <a:prstDash val="solid"/>
           </a:ln>
         </p:spPr>
+        <p:txBody>
+          <a:bodyPr/>
+          <a:p/>
+        </p:txBody>
       </p:sp>
       <p:sp>
         <p:nvSpPr>
@@ -13685,6 +13917,10 @@
             <a:prstDash val="solid"/>
           </a:ln>
         </p:spPr>
+        <p:txBody>
+          <a:bodyPr/>
+          <a:p/>
+        </p:txBody>
       </p:sp>
       <p:sp>
         <p:nvSpPr>
@@ -13762,6 +13998,10 @@
             <a:prstDash val="solid"/>
           </a:ln>
         </p:spPr>
+        <p:txBody>
+          <a:bodyPr/>
+          <a:p/>
+        </p:txBody>
       </p:sp>
       <p:sp>
         <p:nvSpPr>
@@ -13839,6 +14079,10 @@
             <a:prstDash val="solid"/>
           </a:ln>
         </p:spPr>
+        <p:txBody>
+          <a:bodyPr/>
+          <a:p/>
+        </p:txBody>
       </p:sp>
       <p:sp>
         <p:nvSpPr>
@@ -13916,6 +14160,10 @@
             <a:prstDash val="solid"/>
           </a:ln>
         </p:spPr>
+        <p:txBody>
+          <a:bodyPr/>
+          <a:p/>
+        </p:txBody>
       </p:sp>
       <p:sp>
         <p:nvSpPr>
@@ -13993,6 +14241,10 @@
             <a:prstDash val="solid"/>
           </a:ln>
         </p:spPr>
+        <p:txBody>
+          <a:bodyPr/>
+          <a:p/>
+        </p:txBody>
       </p:sp>
       <p:sp>
         <p:nvSpPr>
@@ -14070,6 +14322,10 @@
             <a:prstDash val="solid"/>
           </a:ln>
         </p:spPr>
+        <p:txBody>
+          <a:bodyPr/>
+          <a:p/>
+        </p:txBody>
       </p:sp>
       <p:sp>
         <p:nvSpPr>
@@ -14147,6 +14403,10 @@
             <a:prstDash val="solid"/>
           </a:ln>
         </p:spPr>
+        <p:txBody>
+          <a:bodyPr/>
+          <a:p/>
+        </p:txBody>
       </p:sp>
       <p:sp>
         <p:nvSpPr>
@@ -14260,6 +14520,10 @@
             <a:prstDash val="solid"/>
           </a:ln>
         </p:spPr>
+        <p:txBody>
+          <a:bodyPr/>
+          <a:p/>
+        </p:txBody>
       </p:sp>
       <p:sp>
         <p:nvSpPr>
@@ -14337,6 +14601,10 @@
             <a:prstDash val="solid"/>
           </a:ln>
         </p:spPr>
+        <p:txBody>
+          <a:bodyPr/>
+          <a:p/>
+        </p:txBody>
       </p:sp>
       <p:sp>
         <p:nvSpPr>
@@ -14414,6 +14682,10 @@
             <a:prstDash val="solid"/>
           </a:ln>
         </p:spPr>
+        <p:txBody>
+          <a:bodyPr/>
+          <a:p/>
+        </p:txBody>
       </p:sp>
       <p:sp>
         <p:nvSpPr>
@@ -14491,6 +14763,10 @@
             <a:prstDash val="solid"/>
           </a:ln>
         </p:spPr>
+        <p:txBody>
+          <a:bodyPr/>
+          <a:p/>
+        </p:txBody>
       </p:sp>
       <p:sp>
         <p:nvSpPr>
@@ -14568,6 +14844,10 @@
             <a:prstDash val="solid"/>
           </a:ln>
         </p:spPr>
+        <p:txBody>
+          <a:bodyPr/>
+          <a:p/>
+        </p:txBody>
       </p:sp>
       <p:sp>
         <p:nvSpPr>
@@ -14642,6 +14922,10 @@
             <a:tailEnd type="triangle"/>
           </a:ln>
         </p:spPr>
+        <p:txBody>
+          <a:bodyPr/>
+          <a:p/>
+        </p:txBody>
       </p:sp>
       <p:sp>
         <p:nvSpPr>
@@ -14666,6 +14950,10 @@
             <a:tailEnd type="triangle"/>
           </a:ln>
         </p:spPr>
+        <p:txBody>
+          <a:bodyPr/>
+          <a:p/>
+        </p:txBody>
       </p:sp>
       <p:sp>
         <p:nvSpPr>
@@ -14690,6 +14978,10 @@
             <a:tailEnd type="triangle"/>
           </a:ln>
         </p:spPr>
+        <p:txBody>
+          <a:bodyPr/>
+          <a:p/>
+        </p:txBody>
       </p:sp>
       <p:sp>
         <p:nvSpPr>
@@ -14714,6 +15006,10 @@
             <a:tailEnd type="triangle"/>
           </a:ln>
         </p:spPr>
+        <p:txBody>
+          <a:bodyPr/>
+          <a:p/>
+        </p:txBody>
       </p:sp>
       <p:sp>
         <p:nvSpPr>
@@ -15635,6 +15931,10 @@
             <a:prstDash val="solid"/>
           </a:ln>
         </p:spPr>
+        <p:txBody>
+          <a:bodyPr/>
+          <a:p/>
+        </p:txBody>
       </p:sp>
       <p:sp>
         <p:nvSpPr>
@@ -15660,6 +15960,10 @@
             <a:prstDash val="solid"/>
           </a:ln>
         </p:spPr>
+        <p:txBody>
+          <a:bodyPr/>
+          <a:p/>
+        </p:txBody>
       </p:sp>
       <p:pic>
         <p:nvPicPr>
@@ -15747,6 +16051,10 @@
             <a:prstDash val="solid"/>
           </a:ln>
         </p:spPr>
+        <p:txBody>
+          <a:bodyPr/>
+          <a:p/>
+        </p:txBody>
       </p:sp>
       <p:sp>
         <p:nvSpPr>
@@ -15772,6 +16080,10 @@
             <a:prstDash val="solid"/>
           </a:ln>
         </p:spPr>
+        <p:txBody>
+          <a:bodyPr/>
+          <a:p/>
+        </p:txBody>
       </p:sp>
       <p:pic>
         <p:nvPicPr>
@@ -16863,6 +17175,10 @@
             <a:prstDash val="solid"/>
           </a:ln>
         </p:spPr>
+        <p:txBody>
+          <a:bodyPr/>
+          <a:p/>
+        </p:txBody>
       </p:sp>
       <p:sp>
         <p:nvSpPr>
@@ -17178,6 +17494,10 @@
             <a:prstDash val="solid"/>
           </a:ln>
         </p:spPr>
+        <p:txBody>
+          <a:bodyPr/>
+          <a:p/>
+        </p:txBody>
       </p:sp>
       <p:pic>
         <p:nvPicPr>
@@ -17283,6 +17603,10 @@
             <a:prstDash val="solid"/>
           </a:ln>
         </p:spPr>
+        <p:txBody>
+          <a:bodyPr/>
+          <a:p/>
+        </p:txBody>
       </p:sp>
       <p:pic>
         <p:nvPicPr>
@@ -17388,6 +17712,10 @@
             <a:prstDash val="solid"/>
           </a:ln>
         </p:spPr>
+        <p:txBody>
+          <a:bodyPr/>
+          <a:p/>
+        </p:txBody>
       </p:sp>
       <p:pic>
         <p:nvPicPr>
@@ -17495,6 +17823,10 @@
             <a:prstDash val="solid"/>
           </a:ln>
         </p:spPr>
+        <p:txBody>
+          <a:bodyPr/>
+          <a:p/>
+        </p:txBody>
       </p:sp>
       <p:sp>
         <p:nvSpPr>
@@ -17630,6 +17962,10 @@
             <a:prstDash val="solid"/>
           </a:ln>
         </p:spPr>
+        <p:txBody>
+          <a:bodyPr/>
+          <a:p/>
+        </p:txBody>
       </p:sp>
       <p:sp>
         <p:nvSpPr>
@@ -17765,6 +18101,10 @@
             <a:prstDash val="solid"/>
           </a:ln>
         </p:spPr>
+        <p:txBody>
+          <a:bodyPr/>
+          <a:p/>
+        </p:txBody>
       </p:sp>
       <p:sp>
         <p:nvSpPr>
@@ -17900,6 +18240,10 @@
             <a:prstDash val="solid"/>
           </a:ln>
         </p:spPr>
+        <p:txBody>
+          <a:bodyPr/>
+          <a:p/>
+        </p:txBody>
       </p:sp>
       <p:sp>
         <p:nvSpPr>
@@ -18634,6 +18978,10 @@
             <a:prstDash val="solid"/>
           </a:ln>
         </p:spPr>
+        <p:txBody>
+          <a:bodyPr/>
+          <a:p/>
+        </p:txBody>
       </p:sp>
       <p:sp>
         <p:nvSpPr>
@@ -18659,6 +19007,10 @@
             <a:prstDash val="solid"/>
           </a:ln>
         </p:spPr>
+        <p:txBody>
+          <a:bodyPr/>
+          <a:p/>
+        </p:txBody>
       </p:sp>
       <p:pic>
         <p:nvPicPr>
@@ -22575,6 +22927,10 @@
             <a:prstDash val="solid"/>
           </a:ln>
         </p:spPr>
+        <p:txBody>
+          <a:bodyPr/>
+          <a:p/>
+        </p:txBody>
       </p:sp>
       <p:sp>
         <p:nvSpPr>
@@ -22710,6 +23066,10 @@
             <a:prstDash val="solid"/>
           </a:ln>
         </p:spPr>
+        <p:txBody>
+          <a:bodyPr/>
+          <a:p/>
+        </p:txBody>
       </p:sp>
       <p:sp>
         <p:nvSpPr>
@@ -22845,6 +23205,10 @@
             <a:prstDash val="solid"/>
           </a:ln>
         </p:spPr>
+        <p:txBody>
+          <a:bodyPr/>
+          <a:p/>
+        </p:txBody>
       </p:sp>
       <p:sp>
         <p:nvSpPr>
@@ -23150,6 +23514,10 @@
             <a:prstDash val="solid"/>
           </a:ln>
         </p:spPr>
+        <p:txBody>
+          <a:bodyPr/>
+          <a:p/>
+        </p:txBody>
       </p:sp>
       <p:sp>
         <p:nvSpPr>
@@ -23503,6 +23871,10 @@
             <a:prstDash val="solid"/>
           </a:ln>
         </p:spPr>
+        <p:txBody>
+          <a:bodyPr/>
+          <a:p/>
+        </p:txBody>
       </p:sp>
       <p:sp>
         <p:nvSpPr>
@@ -23566,6 +23938,10 @@
             <a:prstDash val="solid"/>
           </a:ln>
         </p:spPr>
+        <p:txBody>
+          <a:bodyPr/>
+          <a:p/>
+        </p:txBody>
       </p:sp>
       <p:sp>
         <p:nvSpPr>
@@ -23665,6 +24041,10 @@
             <a:prstDash val="solid"/>
           </a:ln>
         </p:spPr>
+        <p:txBody>
+          <a:bodyPr/>
+          <a:p/>
+        </p:txBody>
       </p:sp>
       <p:sp>
         <p:nvSpPr>
@@ -23728,6 +24108,10 @@
             <a:prstDash val="solid"/>
           </a:ln>
         </p:spPr>
+        <p:txBody>
+          <a:bodyPr/>
+          <a:p/>
+        </p:txBody>
       </p:sp>
       <p:sp>
         <p:nvSpPr>
@@ -23935,6 +24319,10 @@
             <a:prstDash val="solid"/>
           </a:ln>
         </p:spPr>
+        <p:txBody>
+          <a:bodyPr/>
+          <a:p/>
+        </p:txBody>
       </p:sp>
       <p:sp>
         <p:nvSpPr>
@@ -23998,6 +24386,10 @@
             <a:prstDash val="solid"/>
           </a:ln>
         </p:spPr>
+        <p:txBody>
+          <a:bodyPr/>
+          <a:p/>
+        </p:txBody>
       </p:sp>
       <p:sp>
         <p:nvSpPr>
@@ -24097,6 +24489,10 @@
             <a:prstDash val="solid"/>
           </a:ln>
         </p:spPr>
+        <p:txBody>
+          <a:bodyPr/>
+          <a:p/>
+        </p:txBody>
       </p:sp>
       <p:sp>
         <p:nvSpPr>
@@ -24160,6 +24556,10 @@
             <a:prstDash val="solid"/>
           </a:ln>
         </p:spPr>
+        <p:txBody>
+          <a:bodyPr/>
+          <a:p/>
+        </p:txBody>
       </p:sp>
       <p:sp>
         <p:nvSpPr>
@@ -24247,6 +24647,10 @@
             <a:prstDash val="solid"/>
           </a:ln>
         </p:spPr>
+        <p:txBody>
+          <a:bodyPr/>
+          <a:p/>
+        </p:txBody>
       </p:sp>
       <p:sp>
         <p:nvSpPr>
@@ -24272,6 +24676,10 @@
             <a:prstDash val="solid"/>
           </a:ln>
         </p:spPr>
+        <p:txBody>
+          <a:bodyPr/>
+          <a:p/>
+        </p:txBody>
       </p:sp>
       <p:pic>
         <p:nvPicPr>
@@ -24643,7 +25051,7 @@
                   <a:schemeClr val="accent1"/>
                 </a:solidFill>
               </a:rPr>
-              <a:t>≈ $4.8</a:t>
+              <a:t>≈ 19 s</a:t>
             </a:r>
             <a:endParaRPr lang="en-US" sz="1400" dirty="0"/>
           </a:p>
@@ -24657,7 +25065,7 @@
                   <a:schemeClr val="accent6"/>
                 </a:solidFill>
               </a:rPr>
-              <a:t>total cloud cost</a:t>
+              <a:t>per epoch (median)</a:t>
             </a:r>
             <a:endParaRPr lang="en-US" sz="1400" dirty="0"/>
           </a:p>
@@ -24775,6 +25183,10 @@
             <a:prstDash val="solid"/>
           </a:ln>
         </p:spPr>
+        <p:txBody>
+          <a:bodyPr/>
+          <a:p/>
+        </p:txBody>
       </p:sp>
       <p:sp>
         <p:nvSpPr>
@@ -24800,6 +25212,10 @@
             <a:prstDash val="solid"/>
           </a:ln>
         </p:spPr>
+        <p:txBody>
+          <a:bodyPr/>
+          <a:p/>
+        </p:txBody>
       </p:sp>
       <p:pic>
         <p:nvPicPr>
@@ -25031,6 +25447,10 @@
             <a:prstDash val="solid"/>
           </a:ln>
         </p:spPr>
+        <p:txBody>
+          <a:bodyPr/>
+          <a:p/>
+        </p:txBody>
       </p:sp>
       <p:pic>
         <p:nvPicPr>
@@ -25136,6 +25556,10 @@
             <a:prstDash val="solid"/>
           </a:ln>
         </p:spPr>
+        <p:txBody>
+          <a:bodyPr/>
+          <a:p/>
+        </p:txBody>
       </p:sp>
       <p:pic>
         <p:nvPicPr>
@@ -25241,6 +25665,10 @@
             <a:prstDash val="solid"/>
           </a:ln>
         </p:spPr>
+        <p:txBody>
+          <a:bodyPr/>
+          <a:p/>
+        </p:txBody>
       </p:sp>
       <p:pic>
         <p:nvPicPr>
@@ -25346,6 +25774,10 @@
             <a:prstDash val="solid"/>
           </a:ln>
         </p:spPr>
+        <p:txBody>
+          <a:bodyPr/>
+          <a:p/>
+        </p:txBody>
       </p:sp>
       <p:pic>
         <p:nvPicPr>
@@ -25451,6 +25883,10 @@
             <a:prstDash val="solid"/>
           </a:ln>
         </p:spPr>
+        <p:txBody>
+          <a:bodyPr/>
+          <a:p/>
+        </p:txBody>
       </p:sp>
       <p:pic>
         <p:nvPicPr>
@@ -25728,6 +26164,10 @@
             <a:prstDash val="solid"/>
           </a:ln>
         </p:spPr>
+        <p:txBody>
+          <a:bodyPr/>
+          <a:p/>
+        </p:txBody>
       </p:sp>
       <p:sp>
         <p:nvSpPr>
@@ -25753,6 +26193,10 @@
             <a:prstDash val="solid"/>
           </a:ln>
         </p:spPr>
+        <p:txBody>
+          <a:bodyPr/>
+          <a:p/>
+        </p:txBody>
       </p:sp>
       <p:pic>
         <p:nvPicPr>
@@ -25978,6 +26422,10 @@
             <a:prstDash val="solid"/>
           </a:ln>
         </p:spPr>
+        <p:txBody>
+          <a:bodyPr/>
+          <a:p/>
+        </p:txBody>
       </p:sp>
       <p:sp>
         <p:nvSpPr>
@@ -26003,6 +26451,10 @@
             <a:prstDash val="solid"/>
           </a:ln>
         </p:spPr>
+        <p:txBody>
+          <a:bodyPr/>
+          <a:p/>
+        </p:txBody>
       </p:sp>
       <p:pic>
         <p:nvPicPr>
@@ -26228,6 +26680,10 @@
             <a:prstDash val="solid"/>
           </a:ln>
         </p:spPr>
+        <p:txBody>
+          <a:bodyPr/>
+          <a:p/>
+        </p:txBody>
       </p:sp>
       <p:sp>
         <p:nvSpPr>
@@ -26253,6 +26709,10 @@
             <a:prstDash val="solid"/>
           </a:ln>
         </p:spPr>
+        <p:txBody>
+          <a:bodyPr/>
+          <a:p/>
+        </p:txBody>
       </p:sp>
       <p:pic>
         <p:nvPicPr>
@@ -28229,6 +28689,10 @@
             <a:prstDash val="solid"/>
           </a:ln>
         </p:spPr>
+        <p:txBody>
+          <a:bodyPr/>
+          <a:p/>
+        </p:txBody>
       </p:sp>
       <p:sp>
         <p:nvSpPr>
@@ -28254,6 +28718,10 @@
             <a:prstDash val="solid"/>
           </a:ln>
         </p:spPr>
+        <p:txBody>
+          <a:bodyPr/>
+          <a:p/>
+        </p:txBody>
       </p:sp>
       <p:pic>
         <p:nvPicPr>
@@ -28361,6 +28829,10 @@
             <a:prstDash val="solid"/>
           </a:ln>
         </p:spPr>
+        <p:txBody>
+          <a:bodyPr/>
+          <a:p/>
+        </p:txBody>
       </p:sp>
       <p:sp>
         <p:nvSpPr>
@@ -28386,6 +28858,10 @@
             <a:prstDash val="solid"/>
           </a:ln>
         </p:spPr>
+        <p:txBody>
+          <a:bodyPr/>
+          <a:p/>
+        </p:txBody>
       </p:sp>
       <p:pic>
         <p:nvPicPr>
@@ -28493,6 +28969,10 @@
             <a:prstDash val="solid"/>
           </a:ln>
         </p:spPr>
+        <p:txBody>
+          <a:bodyPr/>
+          <a:p/>
+        </p:txBody>
       </p:sp>
       <p:sp>
         <p:nvSpPr>
@@ -28518,6 +28998,10 @@
             <a:prstDash val="solid"/>
           </a:ln>
         </p:spPr>
+        <p:txBody>
+          <a:bodyPr/>
+          <a:p/>
+        </p:txBody>
       </p:sp>
       <p:pic>
         <p:nvPicPr>
@@ -28904,6 +29388,10 @@
             <a:prstDash val="solid"/>
           </a:ln>
         </p:spPr>
+        <p:txBody>
+          <a:bodyPr/>
+          <a:p/>
+        </p:txBody>
       </p:sp>
       <p:pic>
         <p:nvPicPr>
@@ -29003,6 +29491,10 @@
             <a:prstDash val="solid"/>
           </a:ln>
         </p:spPr>
+        <p:txBody>
+          <a:bodyPr/>
+          <a:p/>
+        </p:txBody>
       </p:sp>
       <p:pic>
         <p:nvPicPr>
@@ -29102,6 +29594,10 @@
             <a:prstDash val="solid"/>
           </a:ln>
         </p:spPr>
+        <p:txBody>
+          <a:bodyPr/>
+          <a:p/>
+        </p:txBody>
       </p:sp>
       <p:pic>
         <p:nvPicPr>
@@ -29201,6 +29697,10 @@
             <a:prstDash val="solid"/>
           </a:ln>
         </p:spPr>
+        <p:txBody>
+          <a:bodyPr/>
+          <a:p/>
+        </p:txBody>
       </p:sp>
       <p:pic>
         <p:nvPicPr>
@@ -29886,6 +30386,10 @@
             <a:prstDash val="solid"/>
           </a:ln>
         </p:spPr>
+        <p:txBody>
+          <a:bodyPr/>
+          <a:p/>
+        </p:txBody>
       </p:sp>
       <p:pic>
         <p:nvPicPr>
@@ -29991,6 +30495,10 @@
             <a:prstDash val="solid"/>
           </a:ln>
         </p:spPr>
+        <p:txBody>
+          <a:bodyPr/>
+          <a:p/>
+        </p:txBody>
       </p:sp>
       <p:pic>
         <p:nvPicPr>
@@ -30096,6 +30604,10 @@
             <a:prstDash val="solid"/>
           </a:ln>
         </p:spPr>
+        <p:txBody>
+          <a:bodyPr/>
+          <a:p/>
+        </p:txBody>
       </p:sp>
       <p:pic>
         <p:nvPicPr>
@@ -30203,6 +30715,10 @@
             <a:prstDash val="solid"/>
           </a:ln>
         </p:spPr>
+        <p:txBody>
+          <a:bodyPr/>
+          <a:p/>
+        </p:txBody>
       </p:sp>
       <p:sp>
         <p:nvSpPr>
@@ -30589,6 +31105,10 @@
             <a:prstDash val="solid"/>
           </a:ln>
         </p:spPr>
+        <p:txBody>
+          <a:bodyPr/>
+          <a:p/>
+        </p:txBody>
       </p:sp>
       <p:sp>
         <p:nvSpPr>
@@ -30666,6 +31186,10 @@
             <a:prstDash val="solid"/>
           </a:ln>
         </p:spPr>
+        <p:txBody>
+          <a:bodyPr/>
+          <a:p/>
+        </p:txBody>
       </p:sp>
       <p:sp>
         <p:nvSpPr>
@@ -30743,6 +31267,10 @@
             <a:prstDash val="solid"/>
           </a:ln>
         </p:spPr>
+        <p:txBody>
+          <a:bodyPr/>
+          <a:p/>
+        </p:txBody>
       </p:sp>
       <p:sp>
         <p:nvSpPr>
@@ -30916,6 +31444,10 @@
             <a:prstDash val="solid"/>
           </a:ln>
         </p:spPr>
+        <p:txBody>
+          <a:bodyPr/>
+          <a:p/>
+        </p:txBody>
       </p:sp>
       <p:sp>
         <p:nvSpPr>
@@ -30941,6 +31473,10 @@
             <a:prstDash val="solid"/>
           </a:ln>
         </p:spPr>
+        <p:txBody>
+          <a:bodyPr/>
+          <a:p/>
+        </p:txBody>
       </p:sp>
       <p:pic>
         <p:nvPicPr>
@@ -31170,6 +31706,10 @@
             <a:prstDash val="solid"/>
           </a:ln>
         </p:spPr>
+        <p:txBody>
+          <a:bodyPr/>
+          <a:p/>
+        </p:txBody>
       </p:sp>
       <p:sp>
         <p:nvSpPr>
@@ -31231,6 +31771,10 @@
             <a:prstDash val="solid"/>
           </a:ln>
         </p:spPr>
+        <p:txBody>
+          <a:bodyPr/>
+          <a:p/>
+        </p:txBody>
       </p:sp>
       <p:sp>
         <p:nvSpPr>
@@ -31365,6 +31909,10 @@
             <a:prstDash val="solid"/>
           </a:ln>
         </p:spPr>
+        <p:txBody>
+          <a:bodyPr/>
+          <a:p/>
+        </p:txBody>
       </p:sp>
       <p:sp>
         <p:nvSpPr>
@@ -31499,6 +32047,10 @@
             <a:prstDash val="solid"/>
           </a:ln>
         </p:spPr>
+        <p:txBody>
+          <a:bodyPr/>
+          <a:p/>
+        </p:txBody>
       </p:sp>
       <p:sp>
         <p:nvSpPr>
@@ -31633,6 +32185,10 @@
             <a:prstDash val="solid"/>
           </a:ln>
         </p:spPr>
+        <p:txBody>
+          <a:bodyPr/>
+          <a:p/>
+        </p:txBody>
       </p:sp>
       <p:sp>
         <p:nvSpPr>
@@ -31767,6 +32323,10 @@
             <a:prstDash val="solid"/>
           </a:ln>
         </p:spPr>
+        <p:txBody>
+          <a:bodyPr/>
+          <a:p/>
+        </p:txBody>
       </p:sp>
       <p:sp>
         <p:nvSpPr>
@@ -31867,6 +32427,10 @@
             <a:prstDash val="solid"/>
           </a:ln>
         </p:spPr>
+        <p:txBody>
+          <a:bodyPr/>
+          <a:p/>
+        </p:txBody>
       </p:sp>
       <p:sp>
         <p:nvSpPr>
@@ -31892,6 +32456,10 @@
             <a:prstDash val="solid"/>
           </a:ln>
         </p:spPr>
+        <p:txBody>
+          <a:bodyPr/>
+          <a:p/>
+        </p:txBody>
       </p:sp>
       <p:pic>
         <p:nvPicPr>
@@ -32125,6 +32693,10 @@
             <a:prstDash val="solid"/>
           </a:ln>
         </p:spPr>
+        <p:txBody>
+          <a:bodyPr/>
+          <a:p/>
+        </p:txBody>
       </p:sp>
       <p:sp>
         <p:nvSpPr>
@@ -32150,6 +32722,10 @@
             <a:prstDash val="solid"/>
           </a:ln>
         </p:spPr>
+        <p:txBody>
+          <a:bodyPr/>
+          <a:p/>
+        </p:txBody>
       </p:sp>
       <p:pic>
         <p:nvPicPr>
@@ -32273,6 +32849,10 @@
             <a:prstDash val="solid"/>
           </a:ln>
         </p:spPr>
+        <p:txBody>
+          <a:bodyPr/>
+          <a:p/>
+        </p:txBody>
       </p:sp>
       <p:sp>
         <p:nvSpPr>
@@ -32298,6 +32878,10 @@
             <a:prstDash val="solid"/>
           </a:ln>
         </p:spPr>
+        <p:txBody>
+          <a:bodyPr/>
+          <a:p/>
+        </p:txBody>
       </p:sp>
       <p:pic>
         <p:nvPicPr>
@@ -32421,6 +33005,10 @@
             <a:prstDash val="solid"/>
           </a:ln>
         </p:spPr>
+        <p:txBody>
+          <a:bodyPr/>
+          <a:p/>
+        </p:txBody>
       </p:sp>
       <p:sp>
         <p:nvSpPr>
@@ -32446,6 +33034,10 @@
             <a:prstDash val="solid"/>
           </a:ln>
         </p:spPr>
+        <p:txBody>
+          <a:bodyPr/>
+          <a:p/>
+        </p:txBody>
       </p:sp>
       <p:pic>
         <p:nvPicPr>
@@ -32569,6 +33161,10 @@
             <a:prstDash val="solid"/>
           </a:ln>
         </p:spPr>
+        <p:txBody>
+          <a:bodyPr/>
+          <a:p/>
+        </p:txBody>
       </p:sp>
       <p:sp>
         <p:nvSpPr>
@@ -32594,6 +33190,10 @@
             <a:prstDash val="solid"/>
           </a:ln>
         </p:spPr>
+        <p:txBody>
+          <a:bodyPr/>
+          <a:p/>
+        </p:txBody>
       </p:sp>
       <p:pic>
         <p:nvPicPr>
@@ -32717,6 +33317,10 @@
             <a:prstDash val="solid"/>
           </a:ln>
         </p:spPr>
+        <p:txBody>
+          <a:bodyPr/>
+          <a:p/>
+        </p:txBody>
       </p:sp>
       <p:sp>
         <p:nvSpPr>
@@ -32742,6 +33346,10 @@
             <a:prstDash val="solid"/>
           </a:ln>
         </p:spPr>
+        <p:txBody>
+          <a:bodyPr/>
+          <a:p/>
+        </p:txBody>
       </p:sp>
       <p:pic>
         <p:nvPicPr>
@@ -32865,6 +33473,10 @@
             <a:prstDash val="solid"/>
           </a:ln>
         </p:spPr>
+        <p:txBody>
+          <a:bodyPr/>
+          <a:p/>
+        </p:txBody>
       </p:sp>
       <p:sp>
         <p:nvSpPr>
@@ -36612,6 +37224,10 @@
             <a:prstDash val="solid"/>
           </a:ln>
         </p:spPr>
+        <p:txBody>
+          <a:bodyPr/>
+          <a:p/>
+        </p:txBody>
       </p:sp>
       <p:pic>
         <p:nvPicPr>
@@ -36717,6 +37333,10 @@
             <a:prstDash val="solid"/>
           </a:ln>
         </p:spPr>
+        <p:txBody>
+          <a:bodyPr/>
+          <a:p/>
+        </p:txBody>
       </p:sp>
       <p:pic>
         <p:nvPicPr>
@@ -36822,6 +37442,10 @@
             <a:prstDash val="solid"/>
           </a:ln>
         </p:spPr>
+        <p:txBody>
+          <a:bodyPr/>
+          <a:p/>
+        </p:txBody>
       </p:sp>
       <p:pic>
         <p:nvPicPr>

</xml_diff>